<commit_message>
Harden presentation-theme actual evidence gates
</commit_message>
<xml_diff>
--- a/outputs/presentation-theme-actual-tests/jk-theme-canonical-16x9.pptx
+++ b/outputs/presentation-theme-actual-tests/jk-theme-canonical-16x9.pptx
@@ -2,16 +2,16 @@
 <file path=ppt/presentation.xml><?xml version="1.0" encoding="utf-8"?>
 <p:presentation xmlns:p="http://schemas.openxmlformats.org/presentationml/2006/main">
   <p:sldMasterIdLst>
-    <p:sldMasterId xmlns:r="http://schemas.openxmlformats.org/officeDocument/2006/relationships" id="2147483648" r:id="R271e394c50b9419e"/>
+    <p:sldMasterId xmlns:r="http://schemas.openxmlformats.org/officeDocument/2006/relationships" id="2147483648" r:id="R684908843b15437d"/>
   </p:sldMasterIdLst>
   <p:notesMasterIdLst>
-    <p:notesMasterId xmlns:r="http://schemas.openxmlformats.org/officeDocument/2006/relationships" r:id="Rcb8caa1bf34d4e68"/>
+    <p:notesMasterId xmlns:r="http://schemas.openxmlformats.org/officeDocument/2006/relationships" r:id="R5c5ea7bdf7ac4e97"/>
   </p:notesMasterIdLst>
   <p:sldIdLst>
-    <p:sldId xmlns:r="http://schemas.openxmlformats.org/officeDocument/2006/relationships" id="256" r:id="R44ff90c9a94f4b24"/>
-    <p:sldId xmlns:r="http://schemas.openxmlformats.org/officeDocument/2006/relationships" id="257" r:id="R500c1e6c489e421a"/>
-    <p:sldId xmlns:r="http://schemas.openxmlformats.org/officeDocument/2006/relationships" id="258" r:id="Rfe4d35a31ae44203"/>
-    <p:sldId xmlns:r="http://schemas.openxmlformats.org/officeDocument/2006/relationships" id="259" r:id="R325345d83ef742a3"/>
+    <p:sldId xmlns:r="http://schemas.openxmlformats.org/officeDocument/2006/relationships" id="256" r:id="Re71e9d1851614432"/>
+    <p:sldId xmlns:r="http://schemas.openxmlformats.org/officeDocument/2006/relationships" id="257" r:id="Rd31b35b6e3624110"/>
+    <p:sldId xmlns:r="http://schemas.openxmlformats.org/officeDocument/2006/relationships" id="258" r:id="R5a3ad3ddd56a46e5"/>
+    <p:sldId xmlns:r="http://schemas.openxmlformats.org/officeDocument/2006/relationships" id="259" r:id="R00de5ac7bf6e4376"/>
   </p:sldIdLst>
   <p:sldSz cx="12192000" cy="6858000"/>
   <p:notesSz cx="6858000" cy="9144000"/>
@@ -802,7 +802,7 @@
   </p:cSld>
   <p:clrMap bg1="lt1" tx1="dk1" bg2="lt2" tx2="dk2" accent1="accent1" accent2="accent2" accent3="accent3" accent4="accent4" accent5="accent5" accent6="accent6" hlink="hlink" folHlink="folHlink"/>
   <p:sldLayoutIdLst>
-    <p:sldLayoutId xmlns:r="http://schemas.openxmlformats.org/officeDocument/2006/relationships" id="2147483649" r:id="R5c798ad9788c4301"/>
+    <p:sldLayoutId xmlns:r="http://schemas.openxmlformats.org/officeDocument/2006/relationships" id="2147483649" r:id="Re51db86ea0fd45d1"/>
   </p:sldLayoutIdLst>
   <p:txStyles>
     <p:titleStyle>
@@ -1498,7 +1498,7 @@
           <p:cNvPr id="1" name="judgmentkit-title-block-eyebrow">
             <a:extLst xmlns:a="http://schemas.openxmlformats.org/drawingml/2006/main">
               <a:ext uri="{FF2B5EF4-FFF2-40B4-BE49-F238E27FC236}">
-                <a16:creationId xmlns:a16="http://schemas.microsoft.com/office/drawing/2014/main" id="{21C4F1F8-797B-43BB-B490-7B31870CE120}"/>
+                <a16:creationId xmlns:a16="http://schemas.microsoft.com/office/drawing/2014/main" id="{E97B1DF0-626F-4920-A27A-7626DDA50686}"/>
               </a:ext>
             </a:extLst>
           </p:cNvPr>
@@ -1538,7 +1538,7 @@
           <p:cNvPr id="2" name="judgmentkit-title-block-title">
             <a:extLst xmlns:a="http://schemas.openxmlformats.org/drawingml/2006/main">
               <a:ext uri="{FF2B5EF4-FFF2-40B4-BE49-F238E27FC236}">
-                <a16:creationId xmlns:a16="http://schemas.microsoft.com/office/drawing/2014/main" id="{4D71350C-E7AB-4C75-9C6F-ADB0735B4EB9}"/>
+                <a16:creationId xmlns:a16="http://schemas.microsoft.com/office/drawing/2014/main" id="{F651E82A-9461-4185-B2EE-54EB86C0E841}"/>
               </a:ext>
             </a:extLst>
           </p:cNvPr>
@@ -1578,7 +1578,7 @@
           <p:cNvPr id="3" name="judgmentkit-title-block-subtitle">
             <a:extLst xmlns:a="http://schemas.openxmlformats.org/drawingml/2006/main">
               <a:ext uri="{FF2B5EF4-FFF2-40B4-BE49-F238E27FC236}">
-                <a16:creationId xmlns:a16="http://schemas.microsoft.com/office/drawing/2014/main" id="{81ACF6FA-27DA-4672-BE23-4BEB05CAA856}"/>
+                <a16:creationId xmlns:a16="http://schemas.microsoft.com/office/drawing/2014/main" id="{E7A68A76-6C53-44B1-BBB6-646DD3505A52}"/>
               </a:ext>
             </a:extLst>
           </p:cNvPr>
@@ -1618,7 +1618,7 @@
           <p:cNvPr id="4" name="judgmentkit-status-pill-surface">
             <a:extLst xmlns:a="http://schemas.openxmlformats.org/drawingml/2006/main">
               <a:ext uri="{FF2B5EF4-FFF2-40B4-BE49-F238E27FC236}">
-                <a16:creationId xmlns:a16="http://schemas.microsoft.com/office/drawing/2014/main" id="{69CADADD-1138-4F8F-94CE-7DC330E53EDD}"/>
+                <a16:creationId xmlns:a16="http://schemas.microsoft.com/office/drawing/2014/main" id="{E8D4866F-DBC6-4F90-8AF3-AD7AD74F0494}"/>
               </a:ext>
             </a:extLst>
           </p:cNvPr>
@@ -1653,7 +1653,7 @@
           <p:cNvPr id="5" name="judgmentkit-status-pill-label">
             <a:extLst xmlns:a="http://schemas.openxmlformats.org/drawingml/2006/main">
               <a:ext uri="{FF2B5EF4-FFF2-40B4-BE49-F238E27FC236}">
-                <a16:creationId xmlns:a16="http://schemas.microsoft.com/office/drawing/2014/main" id="{44B65158-DE7B-4C76-8634-CE687441B1BC}"/>
+                <a16:creationId xmlns:a16="http://schemas.microsoft.com/office/drawing/2014/main" id="{3D3DBED3-8B40-4F45-8DE3-21173AC511EC}"/>
               </a:ext>
             </a:extLst>
           </p:cNvPr>
@@ -1693,7 +1693,7 @@
           <p:cNvPr id="6" name="canonical-metric-1-surface">
             <a:extLst xmlns:a="http://schemas.openxmlformats.org/drawingml/2006/main">
               <a:ext uri="{FF2B5EF4-FFF2-40B4-BE49-F238E27FC236}">
-                <a16:creationId xmlns:a16="http://schemas.microsoft.com/office/drawing/2014/main" id="{E2E21E4A-6E88-405E-B9BD-1DEC36851BA3}"/>
+                <a16:creationId xmlns:a16="http://schemas.microsoft.com/office/drawing/2014/main" id="{4F43F25C-DD73-49C9-B140-1B230C414C81}"/>
               </a:ext>
             </a:extLst>
           </p:cNvPr>
@@ -1728,7 +1728,7 @@
           <p:cNvPr id="7" name="canonical-metric-1-label">
             <a:extLst xmlns:a="http://schemas.openxmlformats.org/drawingml/2006/main">
               <a:ext uri="{FF2B5EF4-FFF2-40B4-BE49-F238E27FC236}">
-                <a16:creationId xmlns:a16="http://schemas.microsoft.com/office/drawing/2014/main" id="{30DA1111-F27B-41ED-80C2-BED2851F45B0}"/>
+                <a16:creationId xmlns:a16="http://schemas.microsoft.com/office/drawing/2014/main" id="{E66F7FB6-E012-4685-9286-8AD0597B3B82}"/>
               </a:ext>
             </a:extLst>
           </p:cNvPr>
@@ -1768,7 +1768,7 @@
           <p:cNvPr id="8" name="canonical-metric-1-value">
             <a:extLst xmlns:a="http://schemas.openxmlformats.org/drawingml/2006/main">
               <a:ext uri="{FF2B5EF4-FFF2-40B4-BE49-F238E27FC236}">
-                <a16:creationId xmlns:a16="http://schemas.microsoft.com/office/drawing/2014/main" id="{5127E8ED-C5E7-4718-B1DB-E4558F7C481B}"/>
+                <a16:creationId xmlns:a16="http://schemas.microsoft.com/office/drawing/2014/main" id="{395B084E-BB82-4839-A454-76608782BC9B}"/>
               </a:ext>
             </a:extLst>
           </p:cNvPr>
@@ -1808,7 +1808,7 @@
           <p:cNvPr id="9" name="canonical-metric-1-detail">
             <a:extLst xmlns:a="http://schemas.openxmlformats.org/drawingml/2006/main">
               <a:ext uri="{FF2B5EF4-FFF2-40B4-BE49-F238E27FC236}">
-                <a16:creationId xmlns:a16="http://schemas.microsoft.com/office/drawing/2014/main" id="{B0971819-194E-4D07-94D5-3CF696985BC4}"/>
+                <a16:creationId xmlns:a16="http://schemas.microsoft.com/office/drawing/2014/main" id="{31AF4F6A-213D-4BD7-A821-A87CD3003A05}"/>
               </a:ext>
             </a:extLst>
           </p:cNvPr>
@@ -1848,7 +1848,7 @@
           <p:cNvPr id="10" name="canonical-metric-2-surface">
             <a:extLst xmlns:a="http://schemas.openxmlformats.org/drawingml/2006/main">
               <a:ext uri="{FF2B5EF4-FFF2-40B4-BE49-F238E27FC236}">
-                <a16:creationId xmlns:a16="http://schemas.microsoft.com/office/drawing/2014/main" id="{6E6235E3-781A-475F-99DF-A95AD978636B}"/>
+                <a16:creationId xmlns:a16="http://schemas.microsoft.com/office/drawing/2014/main" id="{D8CE6BF9-7C88-4347-9E6C-A3E4C496A4B1}"/>
               </a:ext>
             </a:extLst>
           </p:cNvPr>
@@ -1883,7 +1883,7 @@
           <p:cNvPr id="11" name="canonical-metric-2-label">
             <a:extLst xmlns:a="http://schemas.openxmlformats.org/drawingml/2006/main">
               <a:ext uri="{FF2B5EF4-FFF2-40B4-BE49-F238E27FC236}">
-                <a16:creationId xmlns:a16="http://schemas.microsoft.com/office/drawing/2014/main" id="{72076BDA-6654-4518-B64E-2823C4D09F79}"/>
+                <a16:creationId xmlns:a16="http://schemas.microsoft.com/office/drawing/2014/main" id="{4AD6CBB9-F4CE-4C84-8783-A65674953533}"/>
               </a:ext>
             </a:extLst>
           </p:cNvPr>
@@ -1923,7 +1923,7 @@
           <p:cNvPr id="12" name="canonical-metric-2-value">
             <a:extLst xmlns:a="http://schemas.openxmlformats.org/drawingml/2006/main">
               <a:ext uri="{FF2B5EF4-FFF2-40B4-BE49-F238E27FC236}">
-                <a16:creationId xmlns:a16="http://schemas.microsoft.com/office/drawing/2014/main" id="{B097FCB0-DE03-4034-96D4-CE9C79A4AE57}"/>
+                <a16:creationId xmlns:a16="http://schemas.microsoft.com/office/drawing/2014/main" id="{478E6CA7-6CE3-4936-A03D-6DE071C5D6AA}"/>
               </a:ext>
             </a:extLst>
           </p:cNvPr>
@@ -1963,7 +1963,7 @@
           <p:cNvPr id="13" name="canonical-metric-2-detail">
             <a:extLst xmlns:a="http://schemas.openxmlformats.org/drawingml/2006/main">
               <a:ext uri="{FF2B5EF4-FFF2-40B4-BE49-F238E27FC236}">
-                <a16:creationId xmlns:a16="http://schemas.microsoft.com/office/drawing/2014/main" id="{7B448283-7B4D-41B5-A662-D15077CB5ECA}"/>
+                <a16:creationId xmlns:a16="http://schemas.microsoft.com/office/drawing/2014/main" id="{DD3C98C4-D3EA-4F1F-88D4-F54A2328A756}"/>
               </a:ext>
             </a:extLst>
           </p:cNvPr>
@@ -2003,7 +2003,7 @@
           <p:cNvPr id="14" name="canonical-metric-3-surface">
             <a:extLst xmlns:a="http://schemas.openxmlformats.org/drawingml/2006/main">
               <a:ext uri="{FF2B5EF4-FFF2-40B4-BE49-F238E27FC236}">
-                <a16:creationId xmlns:a16="http://schemas.microsoft.com/office/drawing/2014/main" id="{580C915B-CBD2-4E5D-9B1D-239AF479FB6C}"/>
+                <a16:creationId xmlns:a16="http://schemas.microsoft.com/office/drawing/2014/main" id="{49268A70-097C-42B4-89CF-38F3A936A59F}"/>
               </a:ext>
             </a:extLst>
           </p:cNvPr>
@@ -2038,7 +2038,7 @@
           <p:cNvPr id="15" name="canonical-metric-3-label">
             <a:extLst xmlns:a="http://schemas.openxmlformats.org/drawingml/2006/main">
               <a:ext uri="{FF2B5EF4-FFF2-40B4-BE49-F238E27FC236}">
-                <a16:creationId xmlns:a16="http://schemas.microsoft.com/office/drawing/2014/main" id="{F9FA5CA2-C3CE-4321-9239-30E64D50C8BC}"/>
+                <a16:creationId xmlns:a16="http://schemas.microsoft.com/office/drawing/2014/main" id="{52DCB95D-17D1-4F77-9CBE-81616A70DD45}"/>
               </a:ext>
             </a:extLst>
           </p:cNvPr>
@@ -2078,7 +2078,7 @@
           <p:cNvPr id="16" name="canonical-metric-3-value">
             <a:extLst xmlns:a="http://schemas.openxmlformats.org/drawingml/2006/main">
               <a:ext uri="{FF2B5EF4-FFF2-40B4-BE49-F238E27FC236}">
-                <a16:creationId xmlns:a16="http://schemas.microsoft.com/office/drawing/2014/main" id="{07FB0A50-24C1-4B3A-82E8-3C27CB1A1622}"/>
+                <a16:creationId xmlns:a16="http://schemas.microsoft.com/office/drawing/2014/main" id="{01AD811F-E156-4F8E-A000-9A8296E49DF5}"/>
               </a:ext>
             </a:extLst>
           </p:cNvPr>
@@ -2118,7 +2118,7 @@
           <p:cNvPr id="17" name="canonical-metric-3-detail">
             <a:extLst xmlns:a="http://schemas.openxmlformats.org/drawingml/2006/main">
               <a:ext uri="{FF2B5EF4-FFF2-40B4-BE49-F238E27FC236}">
-                <a16:creationId xmlns:a16="http://schemas.microsoft.com/office/drawing/2014/main" id="{F934D25A-E55E-47BB-B3CC-C71F55B2AF4B}"/>
+                <a16:creationId xmlns:a16="http://schemas.microsoft.com/office/drawing/2014/main" id="{6B7EAF22-D855-406B-A52B-AEC4213CF973}"/>
               </a:ext>
             </a:extLst>
           </p:cNvPr>
@@ -2156,7 +2156,7 @@
     </p:spTree>
     <p:extLst>
       <p:ext uri="{BB962C8B-B14F-4D97-AF65-F5344CB8AC3E}">
-        <p14:creationId xmlns:p14="http://schemas.microsoft.com/office/powerpoint/2010/main" val="1580781288"/>
+        <p14:creationId xmlns:p14="http://schemas.microsoft.com/office/powerpoint/2010/main" val="413739363"/>
       </p:ext>
     </p:extLst>
   </p:cSld>
@@ -2187,7 +2187,7 @@
           <p:cNvPr id="1" name="judgmentkit-section-header-label">
             <a:extLst xmlns:a="http://schemas.openxmlformats.org/drawingml/2006/main">
               <a:ext uri="{FF2B5EF4-FFF2-40B4-BE49-F238E27FC236}">
-                <a16:creationId xmlns:a16="http://schemas.microsoft.com/office/drawing/2014/main" id="{ADF4E761-3055-4287-BEE6-A63869D9E61F}"/>
+                <a16:creationId xmlns:a16="http://schemas.microsoft.com/office/drawing/2014/main" id="{DBADBFFC-E3C1-42A0-9B3F-5525AFFCD550}"/>
               </a:ext>
             </a:extLst>
           </p:cNvPr>
@@ -2227,7 +2227,7 @@
           <p:cNvPr id="2" name="judgmentkit-section-header-title">
             <a:extLst xmlns:a="http://schemas.openxmlformats.org/drawingml/2006/main">
               <a:ext uri="{FF2B5EF4-FFF2-40B4-BE49-F238E27FC236}">
-                <a16:creationId xmlns:a16="http://schemas.microsoft.com/office/drawing/2014/main" id="{27B79BB1-3284-4E08-96B6-094335E6BBD1}"/>
+                <a16:creationId xmlns:a16="http://schemas.microsoft.com/office/drawing/2014/main" id="{579ECA83-4A22-4B54-A815-D9AE808C60C1}"/>
               </a:ext>
             </a:extLst>
           </p:cNvPr>
@@ -2267,7 +2267,7 @@
           <p:cNvPr id="3" name="judgmentkit-evidence-panel-surface">
             <a:extLst xmlns:a="http://schemas.openxmlformats.org/drawingml/2006/main">
               <a:ext uri="{FF2B5EF4-FFF2-40B4-BE49-F238E27FC236}">
-                <a16:creationId xmlns:a16="http://schemas.microsoft.com/office/drawing/2014/main" id="{F64B51BA-7827-4141-A1B5-3CD8FB1B7A46}"/>
+                <a16:creationId xmlns:a16="http://schemas.microsoft.com/office/drawing/2014/main" id="{324E8A49-158C-4B81-8D0E-20C68FC99395}"/>
               </a:ext>
             </a:extLst>
           </p:cNvPr>
@@ -2302,7 +2302,7 @@
           <p:cNvPr id="4" name="judgmentkit-evidence-panel-title">
             <a:extLst xmlns:a="http://schemas.openxmlformats.org/drawingml/2006/main">
               <a:ext uri="{FF2B5EF4-FFF2-40B4-BE49-F238E27FC236}">
-                <a16:creationId xmlns:a16="http://schemas.microsoft.com/office/drawing/2014/main" id="{0E2C70BE-ED76-482E-9EFF-E2F75036C369}"/>
+                <a16:creationId xmlns:a16="http://schemas.microsoft.com/office/drawing/2014/main" id="{B8FB7A17-2DF1-4BAA-B712-83891FA03BC1}"/>
               </a:ext>
             </a:extLst>
           </p:cNvPr>
@@ -2342,7 +2342,7 @@
           <p:cNvPr id="5" name="judgmentkit-evidence-panel-body">
             <a:extLst xmlns:a="http://schemas.openxmlformats.org/drawingml/2006/main">
               <a:ext uri="{FF2B5EF4-FFF2-40B4-BE49-F238E27FC236}">
-                <a16:creationId xmlns:a16="http://schemas.microsoft.com/office/drawing/2014/main" id="{D0A7EE9A-C923-4D50-B297-2B2FEE4CA30A}"/>
+                <a16:creationId xmlns:a16="http://schemas.microsoft.com/office/drawing/2014/main" id="{E5BB95CA-2D8D-44EC-9345-EC5A01D8349B}"/>
               </a:ext>
             </a:extLst>
           </p:cNvPr>
@@ -2406,7 +2406,7 @@
           <p:cNvPr id="6" name="judgmentkit-risk-callout-surface">
             <a:extLst xmlns:a="http://schemas.openxmlformats.org/drawingml/2006/main">
               <a:ext uri="{FF2B5EF4-FFF2-40B4-BE49-F238E27FC236}">
-                <a16:creationId xmlns:a16="http://schemas.microsoft.com/office/drawing/2014/main" id="{50A562F2-0E38-4E02-8390-981631D4898D}"/>
+                <a16:creationId xmlns:a16="http://schemas.microsoft.com/office/drawing/2014/main" id="{FFB9294C-4A5A-4155-81C0-04A54D718153}"/>
               </a:ext>
             </a:extLst>
           </p:cNvPr>
@@ -2441,7 +2441,7 @@
           <p:cNvPr id="7" name="judgmentkit-risk-callout-title">
             <a:extLst xmlns:a="http://schemas.openxmlformats.org/drawingml/2006/main">
               <a:ext uri="{FF2B5EF4-FFF2-40B4-BE49-F238E27FC236}">
-                <a16:creationId xmlns:a16="http://schemas.microsoft.com/office/drawing/2014/main" id="{368BF0A1-A2E7-4BB5-950E-D4B9CF46BC97}"/>
+                <a16:creationId xmlns:a16="http://schemas.microsoft.com/office/drawing/2014/main" id="{C5CCDE8A-3705-4A12-AAE1-C6221C63C21B}"/>
               </a:ext>
             </a:extLst>
           </p:cNvPr>
@@ -2481,7 +2481,7 @@
           <p:cNvPr id="8" name="judgmentkit-risk-callout-body">
             <a:extLst xmlns:a="http://schemas.openxmlformats.org/drawingml/2006/main">
               <a:ext uri="{FF2B5EF4-FFF2-40B4-BE49-F238E27FC236}">
-                <a16:creationId xmlns:a16="http://schemas.microsoft.com/office/drawing/2014/main" id="{4401A2CA-B890-49D1-942C-D23F1E944D3C}"/>
+                <a16:creationId xmlns:a16="http://schemas.microsoft.com/office/drawing/2014/main" id="{D3988DFA-5309-410D-BFC9-B1B78F6F37C3}"/>
               </a:ext>
             </a:extLst>
           </p:cNvPr>
@@ -2533,7 +2533,7 @@
           <p:cNvPr id="9" name="judgmentkit-handoff-receipt-surface">
             <a:extLst xmlns:a="http://schemas.openxmlformats.org/drawingml/2006/main">
               <a:ext uri="{FF2B5EF4-FFF2-40B4-BE49-F238E27FC236}">
-                <a16:creationId xmlns:a16="http://schemas.microsoft.com/office/drawing/2014/main" id="{1FB94ED3-E825-4739-847A-17F9714EB2EE}"/>
+                <a16:creationId xmlns:a16="http://schemas.microsoft.com/office/drawing/2014/main" id="{B434601D-4227-4CD4-815C-C5FF9D08A077}"/>
               </a:ext>
             </a:extLst>
           </p:cNvPr>
@@ -2568,7 +2568,7 @@
           <p:cNvPr id="10" name="judgmentkit-handoff-receipt-title">
             <a:extLst xmlns:a="http://schemas.openxmlformats.org/drawingml/2006/main">
               <a:ext uri="{FF2B5EF4-FFF2-40B4-BE49-F238E27FC236}">
-                <a16:creationId xmlns:a16="http://schemas.microsoft.com/office/drawing/2014/main" id="{E3FC26DD-0E36-46C8-913C-B120F946CEE3}"/>
+                <a16:creationId xmlns:a16="http://schemas.microsoft.com/office/drawing/2014/main" id="{5C4B5225-3910-4A97-B30D-2880C4E3C961}"/>
               </a:ext>
             </a:extLst>
           </p:cNvPr>
@@ -2608,7 +2608,7 @@
           <p:cNvPr id="11" name="judgmentkit-handoff-receipt-body">
             <a:extLst xmlns:a="http://schemas.openxmlformats.org/drawingml/2006/main">
               <a:ext uri="{FF2B5EF4-FFF2-40B4-BE49-F238E27FC236}">
-                <a16:creationId xmlns:a16="http://schemas.microsoft.com/office/drawing/2014/main" id="{8F420854-B1ED-4495-BC5F-5CBC7E95F30D}"/>
+                <a16:creationId xmlns:a16="http://schemas.microsoft.com/office/drawing/2014/main" id="{C413FE42-FD7F-4971-82B4-29EF079A7C65}"/>
               </a:ext>
             </a:extLst>
           </p:cNvPr>
@@ -2646,7 +2646,7 @@
     </p:spTree>
     <p:extLst>
       <p:ext uri="{BB962C8B-B14F-4D97-AF65-F5344CB8AC3E}">
-        <p14:creationId xmlns:p14="http://schemas.microsoft.com/office/powerpoint/2010/main" val="374896175"/>
+        <p14:creationId xmlns:p14="http://schemas.microsoft.com/office/powerpoint/2010/main" val="1353852943"/>
       </p:ext>
     </p:extLst>
   </p:cSld>
@@ -2677,7 +2677,7 @@
           <p:cNvPr id="1" name="judgmentkit-section-header-label">
             <a:extLst xmlns:a="http://schemas.openxmlformats.org/drawingml/2006/main">
               <a:ext uri="{FF2B5EF4-FFF2-40B4-BE49-F238E27FC236}">
-                <a16:creationId xmlns:a16="http://schemas.microsoft.com/office/drawing/2014/main" id="{60AFB422-14A2-4DDA-9760-725448F4E384}"/>
+                <a16:creationId xmlns:a16="http://schemas.microsoft.com/office/drawing/2014/main" id="{93E84FE7-A258-4C87-BE7B-BD9423A5C45B}"/>
               </a:ext>
             </a:extLst>
           </p:cNvPr>
@@ -2717,7 +2717,7 @@
           <p:cNvPr id="2" name="judgmentkit-section-header-title">
             <a:extLst xmlns:a="http://schemas.openxmlformats.org/drawingml/2006/main">
               <a:ext uri="{FF2B5EF4-FFF2-40B4-BE49-F238E27FC236}">
-                <a16:creationId xmlns:a16="http://schemas.microsoft.com/office/drawing/2014/main" id="{97197181-E4AC-4041-B52E-175A69BD1424}"/>
+                <a16:creationId xmlns:a16="http://schemas.microsoft.com/office/drawing/2014/main" id="{8B1C893B-3A54-4A60-8231-4D9B4395F875}"/>
               </a:ext>
             </a:extLst>
           </p:cNvPr>
@@ -2757,7 +2757,7 @@
           <p:cNvPr id="3" name="judgmentkit-media-frame">
             <a:extLst xmlns:a="http://schemas.openxmlformats.org/drawingml/2006/main">
               <a:ext uri="{FF2B5EF4-FFF2-40B4-BE49-F238E27FC236}">
-                <a16:creationId xmlns:a16="http://schemas.microsoft.com/office/drawing/2014/main" id="{EE31EAB5-3EA4-423E-8B7A-3244A70970C7}"/>
+                <a16:creationId xmlns:a16="http://schemas.microsoft.com/office/drawing/2014/main" id="{E79A668E-2762-4557-AC9D-8EBB2084CCEB}"/>
               </a:ext>
             </a:extLst>
           </p:cNvPr>
@@ -2799,14 +2799,14 @@
         </p:xfrm>
         <a:graphic xmlns:a="http://schemas.openxmlformats.org/drawingml/2006/main">
           <a:graphicData uri="http://schemas.openxmlformats.org/drawingml/2006/chart">
-            <c:chart xmlns:r="http://schemas.openxmlformats.org/officeDocument/2006/relationships" xmlns:c="http://schemas.openxmlformats.org/drawingml/2006/chart" r:id="Raeca061fd5d94e6d"/>
+            <c:chart xmlns:r="http://schemas.openxmlformats.org/officeDocument/2006/relationships" xmlns:c="http://schemas.openxmlformats.org/drawingml/2006/chart" r:id="Rabfed9e51d0841d2"/>
           </a:graphicData>
         </a:graphic>
       </p:graphicFrame>
     </p:spTree>
     <p:extLst>
       <p:ext uri="{BB962C8B-B14F-4D97-AF65-F5344CB8AC3E}">
-        <p14:creationId xmlns:p14="http://schemas.microsoft.com/office/powerpoint/2010/main" val="988533220"/>
+        <p14:creationId xmlns:p14="http://schemas.microsoft.com/office/powerpoint/2010/main" val="1336040462"/>
       </p:ext>
     </p:extLst>
   </p:cSld>
@@ -2837,7 +2837,7 @@
           <p:cNvPr id="1" name="judgmentkit-section-header-label">
             <a:extLst xmlns:a="http://schemas.openxmlformats.org/drawingml/2006/main">
               <a:ext uri="{FF2B5EF4-FFF2-40B4-BE49-F238E27FC236}">
-                <a16:creationId xmlns:a16="http://schemas.microsoft.com/office/drawing/2014/main" id="{9FC2BA84-18FA-4AD3-AE01-FC14CCC7F649}"/>
+                <a16:creationId xmlns:a16="http://schemas.microsoft.com/office/drawing/2014/main" id="{2A1E9F05-C512-4195-92EA-E59492838F17}"/>
               </a:ext>
             </a:extLst>
           </p:cNvPr>
@@ -2877,7 +2877,7 @@
           <p:cNvPr id="2" name="judgmentkit-section-header-title">
             <a:extLst xmlns:a="http://schemas.openxmlformats.org/drawingml/2006/main">
               <a:ext uri="{FF2B5EF4-FFF2-40B4-BE49-F238E27FC236}">
-                <a16:creationId xmlns:a16="http://schemas.microsoft.com/office/drawing/2014/main" id="{EA0F2DED-FEC3-4B48-8D20-90E2E5657CBD}"/>
+                <a16:creationId xmlns:a16="http://schemas.microsoft.com/office/drawing/2014/main" id="{9C4F8741-4E50-4C27-869E-ED31EE788977}"/>
               </a:ext>
             </a:extLst>
           </p:cNvPr>
@@ -3092,7 +3092,7 @@
           <p:cNvPr id="4" name="judgmentkit-handoff-receipt-surface">
             <a:extLst xmlns:a="http://schemas.openxmlformats.org/drawingml/2006/main">
               <a:ext uri="{FF2B5EF4-FFF2-40B4-BE49-F238E27FC236}">
-                <a16:creationId xmlns:a16="http://schemas.microsoft.com/office/drawing/2014/main" id="{E9165E80-DC20-4076-ABBB-0E9F2319589C}"/>
+                <a16:creationId xmlns:a16="http://schemas.microsoft.com/office/drawing/2014/main" id="{3B83D51D-4E33-4B7F-A29B-1A41CB3F0622}"/>
               </a:ext>
             </a:extLst>
           </p:cNvPr>
@@ -3127,7 +3127,7 @@
           <p:cNvPr id="5" name="judgmentkit-handoff-receipt-title">
             <a:extLst xmlns:a="http://schemas.openxmlformats.org/drawingml/2006/main">
               <a:ext uri="{FF2B5EF4-FFF2-40B4-BE49-F238E27FC236}">
-                <a16:creationId xmlns:a16="http://schemas.microsoft.com/office/drawing/2014/main" id="{14864B90-4AD2-4C89-9B05-9F8C68C4BFE3}"/>
+                <a16:creationId xmlns:a16="http://schemas.microsoft.com/office/drawing/2014/main" id="{3DBE748D-38B0-4B3E-9E42-BCC6A7EB6E84}"/>
               </a:ext>
             </a:extLst>
           </p:cNvPr>
@@ -3167,7 +3167,7 @@
           <p:cNvPr id="6" name="judgmentkit-handoff-receipt-body">
             <a:extLst xmlns:a="http://schemas.openxmlformats.org/drawingml/2006/main">
               <a:ext uri="{FF2B5EF4-FFF2-40B4-BE49-F238E27FC236}">
-                <a16:creationId xmlns:a16="http://schemas.microsoft.com/office/drawing/2014/main" id="{45D10446-60D8-44BD-8BBD-B9CFCDF37417}"/>
+                <a16:creationId xmlns:a16="http://schemas.microsoft.com/office/drawing/2014/main" id="{02D1ED43-49B6-414C-9B85-0B42458453E8}"/>
               </a:ext>
             </a:extLst>
           </p:cNvPr>
@@ -3205,7 +3205,7 @@
     </p:spTree>
     <p:extLst>
       <p:ext uri="{BB962C8B-B14F-4D97-AF65-F5344CB8AC3E}">
-        <p14:creationId xmlns:p14="http://schemas.microsoft.com/office/powerpoint/2010/main" val="45231195"/>
+        <p14:creationId xmlns:p14="http://schemas.microsoft.com/office/powerpoint/2010/main" val="1137586105"/>
       </p:ext>
     </p:extLst>
   </p:cSld>

</xml_diff>

<commit_message>
Harden presentation theme evidence review
</commit_message>
<xml_diff>
--- a/outputs/presentation-theme-actual-tests/jk-theme-canonical-16x9.pptx
+++ b/outputs/presentation-theme-actual-tests/jk-theme-canonical-16x9.pptx
@@ -2,16 +2,16 @@
 <file path=ppt/presentation.xml><?xml version="1.0" encoding="utf-8"?>
 <p:presentation xmlns:p="http://schemas.openxmlformats.org/presentationml/2006/main">
   <p:sldMasterIdLst>
-    <p:sldMasterId xmlns:r="http://schemas.openxmlformats.org/officeDocument/2006/relationships" id="2147483648" r:id="R684908843b15437d"/>
+    <p:sldMasterId xmlns:r="http://schemas.openxmlformats.org/officeDocument/2006/relationships" id="2147483648" r:id="Rfe72865c106e49be"/>
   </p:sldMasterIdLst>
   <p:notesMasterIdLst>
-    <p:notesMasterId xmlns:r="http://schemas.openxmlformats.org/officeDocument/2006/relationships" r:id="R5c5ea7bdf7ac4e97"/>
+    <p:notesMasterId xmlns:r="http://schemas.openxmlformats.org/officeDocument/2006/relationships" r:id="Rf1f759d251f84597"/>
   </p:notesMasterIdLst>
   <p:sldIdLst>
-    <p:sldId xmlns:r="http://schemas.openxmlformats.org/officeDocument/2006/relationships" id="256" r:id="Re71e9d1851614432"/>
-    <p:sldId xmlns:r="http://schemas.openxmlformats.org/officeDocument/2006/relationships" id="257" r:id="Rd31b35b6e3624110"/>
-    <p:sldId xmlns:r="http://schemas.openxmlformats.org/officeDocument/2006/relationships" id="258" r:id="R5a3ad3ddd56a46e5"/>
-    <p:sldId xmlns:r="http://schemas.openxmlformats.org/officeDocument/2006/relationships" id="259" r:id="R00de5ac7bf6e4376"/>
+    <p:sldId xmlns:r="http://schemas.openxmlformats.org/officeDocument/2006/relationships" id="256" r:id="R44561aa9e85b4835"/>
+    <p:sldId xmlns:r="http://schemas.openxmlformats.org/officeDocument/2006/relationships" id="257" r:id="R82b0e4cb96df4275"/>
+    <p:sldId xmlns:r="http://schemas.openxmlformats.org/officeDocument/2006/relationships" id="258" r:id="Re2b42f8d9f92445a"/>
+    <p:sldId xmlns:r="http://schemas.openxmlformats.org/officeDocument/2006/relationships" id="259" r:id="R16b53eb4cf5a4da9"/>
   </p:sldIdLst>
   <p:sldSz cx="12192000" cy="6858000"/>
   <p:notesSz cx="6858000" cy="9144000"/>
@@ -263,19 +263,19 @@
         <a:srgbClr val="171717"/>
       </a:dk1>
       <a:lt1>
-        <a:srgbClr val="F8F7F2"/>
+        <a:srgbClr val="FFFFFF"/>
       </a:lt1>
       <a:dk2>
-        <a:srgbClr val="61615C"/>
+        <a:srgbClr val="666666"/>
       </a:dk2>
       <a:lt2>
-        <a:srgbClr val="FFFFFF"/>
+        <a:srgbClr val="F4F4F4"/>
       </a:lt2>
       <a:accent1>
-        <a:srgbClr val="245F73"/>
+        <a:srgbClr val="156082"/>
       </a:accent1>
       <a:accent2>
-        <a:srgbClr val="23615F"/>
+        <a:srgbClr val="467886"/>
       </a:accent2>
       <a:accent3>
         <a:srgbClr val="2E6B48"/>
@@ -287,13 +287,13 @@
         <a:srgbClr val="8F342F"/>
       </a:accent5>
       <a:accent6>
-        <a:srgbClr val="D7D3C8"/>
+        <a:srgbClr val="D9D9D9"/>
       </a:accent6>
       <a:hlink>
-        <a:srgbClr val="245F73"/>
+        <a:srgbClr val="156082"/>
       </a:hlink>
       <a:folHlink>
-        <a:srgbClr val="23615F"/>
+        <a:srgbClr val="467886"/>
       </a:folHlink>
     </a:clrScheme>
     <a:fontScheme name="Office">
@@ -802,7 +802,7 @@
   </p:cSld>
   <p:clrMap bg1="lt1" tx1="dk1" bg2="lt2" tx2="dk2" accent1="accent1" accent2="accent2" accent3="accent3" accent4="accent4" accent5="accent5" accent6="accent6" hlink="hlink" folHlink="folHlink"/>
   <p:sldLayoutIdLst>
-    <p:sldLayoutId xmlns:r="http://schemas.openxmlformats.org/officeDocument/2006/relationships" id="2147483649" r:id="Re51db86ea0fd45d1"/>
+    <p:sldLayoutId xmlns:r="http://schemas.openxmlformats.org/officeDocument/2006/relationships" id="2147483649" r:id="R9d46222f10ad4069"/>
   </p:sldLayoutIdLst>
   <p:txStyles>
     <p:titleStyle>
@@ -1092,19 +1092,19 @@
         <a:srgbClr val="171717"/>
       </a:dk1>
       <a:lt1>
-        <a:srgbClr val="F8F7F2"/>
+        <a:srgbClr val="FFFFFF"/>
       </a:lt1>
       <a:dk2>
-        <a:srgbClr val="61615C"/>
+        <a:srgbClr val="666666"/>
       </a:dk2>
       <a:lt2>
-        <a:srgbClr val="FFFFFF"/>
+        <a:srgbClr val="F4F4F4"/>
       </a:lt2>
       <a:accent1>
-        <a:srgbClr val="245F73"/>
+        <a:srgbClr val="156082"/>
       </a:accent1>
       <a:accent2>
-        <a:srgbClr val="23615F"/>
+        <a:srgbClr val="467886"/>
       </a:accent2>
       <a:accent3>
         <a:srgbClr val="2E6B48"/>
@@ -1116,13 +1116,13 @@
         <a:srgbClr val="8F342F"/>
       </a:accent5>
       <a:accent6>
-        <a:srgbClr val="D7D3C8"/>
+        <a:srgbClr val="D9D9D9"/>
       </a:accent6>
       <a:hlink>
-        <a:srgbClr val="245F73"/>
+        <a:srgbClr val="156082"/>
       </a:hlink>
       <a:folHlink>
-        <a:srgbClr val="23615F"/>
+        <a:srgbClr val="467886"/>
       </a:folHlink>
     </a:clrScheme>
     <a:fontScheme name="Office">
@@ -1498,7 +1498,7 @@
           <p:cNvPr id="1" name="judgmentkit-title-block-eyebrow">
             <a:extLst xmlns:a="http://schemas.openxmlformats.org/drawingml/2006/main">
               <a:ext uri="{FF2B5EF4-FFF2-40B4-BE49-F238E27FC236}">
-                <a16:creationId xmlns:a16="http://schemas.microsoft.com/office/drawing/2014/main" id="{E97B1DF0-626F-4920-A27A-7626DDA50686}"/>
+                <a16:creationId xmlns:a16="http://schemas.microsoft.com/office/drawing/2014/main" id="{49A5F0B4-AC03-4BAA-92BD-C2E66B92C975}"/>
               </a:ext>
             </a:extLst>
           </p:cNvPr>
@@ -1538,7 +1538,7 @@
           <p:cNvPr id="2" name="judgmentkit-title-block-title">
             <a:extLst xmlns:a="http://schemas.openxmlformats.org/drawingml/2006/main">
               <a:ext uri="{FF2B5EF4-FFF2-40B4-BE49-F238E27FC236}">
-                <a16:creationId xmlns:a16="http://schemas.microsoft.com/office/drawing/2014/main" id="{F651E82A-9461-4185-B2EE-54EB86C0E841}"/>
+                <a16:creationId xmlns:a16="http://schemas.microsoft.com/office/drawing/2014/main" id="{02D5873A-231C-446E-9452-4845A68E03A9}"/>
               </a:ext>
             </a:extLst>
           </p:cNvPr>
@@ -1578,7 +1578,7 @@
           <p:cNvPr id="3" name="judgmentkit-title-block-subtitle">
             <a:extLst xmlns:a="http://schemas.openxmlformats.org/drawingml/2006/main">
               <a:ext uri="{FF2B5EF4-FFF2-40B4-BE49-F238E27FC236}">
-                <a16:creationId xmlns:a16="http://schemas.microsoft.com/office/drawing/2014/main" id="{E7A68A76-6C53-44B1-BBB6-646DD3505A52}"/>
+                <a16:creationId xmlns:a16="http://schemas.microsoft.com/office/drawing/2014/main" id="{491C57AE-2F23-4EF5-922B-C371E6A263A2}"/>
               </a:ext>
             </a:extLst>
           </p:cNvPr>
@@ -1618,7 +1618,7 @@
           <p:cNvPr id="4" name="judgmentkit-status-pill-surface">
             <a:extLst xmlns:a="http://schemas.openxmlformats.org/drawingml/2006/main">
               <a:ext uri="{FF2B5EF4-FFF2-40B4-BE49-F238E27FC236}">
-                <a16:creationId xmlns:a16="http://schemas.microsoft.com/office/drawing/2014/main" id="{E8D4866F-DBC6-4F90-8AF3-AD7AD74F0494}"/>
+                <a16:creationId xmlns:a16="http://schemas.microsoft.com/office/drawing/2014/main" id="{2754E1BC-C938-45E9-A506-AECCF034CA9D}"/>
               </a:ext>
             </a:extLst>
           </p:cNvPr>
@@ -1653,7 +1653,7 @@
           <p:cNvPr id="5" name="judgmentkit-status-pill-label">
             <a:extLst xmlns:a="http://schemas.openxmlformats.org/drawingml/2006/main">
               <a:ext uri="{FF2B5EF4-FFF2-40B4-BE49-F238E27FC236}">
-                <a16:creationId xmlns:a16="http://schemas.microsoft.com/office/drawing/2014/main" id="{3D3DBED3-8B40-4F45-8DE3-21173AC511EC}"/>
+                <a16:creationId xmlns:a16="http://schemas.microsoft.com/office/drawing/2014/main" id="{3471AC9A-38FF-4B00-9C77-BC741D8B98FC}"/>
               </a:ext>
             </a:extLst>
           </p:cNvPr>
@@ -1693,7 +1693,7 @@
           <p:cNvPr id="6" name="canonical-metric-1-surface">
             <a:extLst xmlns:a="http://schemas.openxmlformats.org/drawingml/2006/main">
               <a:ext uri="{FF2B5EF4-FFF2-40B4-BE49-F238E27FC236}">
-                <a16:creationId xmlns:a16="http://schemas.microsoft.com/office/drawing/2014/main" id="{4F43F25C-DD73-49C9-B140-1B230C414C81}"/>
+                <a16:creationId xmlns:a16="http://schemas.microsoft.com/office/drawing/2014/main" id="{18FCD8F7-7474-4946-A060-D9B8E482C1DC}"/>
               </a:ext>
             </a:extLst>
           </p:cNvPr>
@@ -1728,7 +1728,7 @@
           <p:cNvPr id="7" name="canonical-metric-1-label">
             <a:extLst xmlns:a="http://schemas.openxmlformats.org/drawingml/2006/main">
               <a:ext uri="{FF2B5EF4-FFF2-40B4-BE49-F238E27FC236}">
-                <a16:creationId xmlns:a16="http://schemas.microsoft.com/office/drawing/2014/main" id="{E66F7FB6-E012-4685-9286-8AD0597B3B82}"/>
+                <a16:creationId xmlns:a16="http://schemas.microsoft.com/office/drawing/2014/main" id="{D3F30CEE-FD3B-41E4-A113-32DBBABBF007}"/>
               </a:ext>
             </a:extLst>
           </p:cNvPr>
@@ -1768,7 +1768,7 @@
           <p:cNvPr id="8" name="canonical-metric-1-value">
             <a:extLst xmlns:a="http://schemas.openxmlformats.org/drawingml/2006/main">
               <a:ext uri="{FF2B5EF4-FFF2-40B4-BE49-F238E27FC236}">
-                <a16:creationId xmlns:a16="http://schemas.microsoft.com/office/drawing/2014/main" id="{395B084E-BB82-4839-A454-76608782BC9B}"/>
+                <a16:creationId xmlns:a16="http://schemas.microsoft.com/office/drawing/2014/main" id="{DA7E7CE1-61C8-47C2-BF66-62C5C295BA95}"/>
               </a:ext>
             </a:extLst>
           </p:cNvPr>
@@ -1808,7 +1808,7 @@
           <p:cNvPr id="9" name="canonical-metric-1-detail">
             <a:extLst xmlns:a="http://schemas.openxmlformats.org/drawingml/2006/main">
               <a:ext uri="{FF2B5EF4-FFF2-40B4-BE49-F238E27FC236}">
-                <a16:creationId xmlns:a16="http://schemas.microsoft.com/office/drawing/2014/main" id="{31AF4F6A-213D-4BD7-A821-A87CD3003A05}"/>
+                <a16:creationId xmlns:a16="http://schemas.microsoft.com/office/drawing/2014/main" id="{E49F0093-209C-4E70-9F66-0CB83679776D}"/>
               </a:ext>
             </a:extLst>
           </p:cNvPr>
@@ -1848,7 +1848,7 @@
           <p:cNvPr id="10" name="canonical-metric-2-surface">
             <a:extLst xmlns:a="http://schemas.openxmlformats.org/drawingml/2006/main">
               <a:ext uri="{FF2B5EF4-FFF2-40B4-BE49-F238E27FC236}">
-                <a16:creationId xmlns:a16="http://schemas.microsoft.com/office/drawing/2014/main" id="{D8CE6BF9-7C88-4347-9E6C-A3E4C496A4B1}"/>
+                <a16:creationId xmlns:a16="http://schemas.microsoft.com/office/drawing/2014/main" id="{6D897D56-ADCB-42D9-BD42-04828D1243DB}"/>
               </a:ext>
             </a:extLst>
           </p:cNvPr>
@@ -1883,7 +1883,7 @@
           <p:cNvPr id="11" name="canonical-metric-2-label">
             <a:extLst xmlns:a="http://schemas.openxmlformats.org/drawingml/2006/main">
               <a:ext uri="{FF2B5EF4-FFF2-40B4-BE49-F238E27FC236}">
-                <a16:creationId xmlns:a16="http://schemas.microsoft.com/office/drawing/2014/main" id="{4AD6CBB9-F4CE-4C84-8783-A65674953533}"/>
+                <a16:creationId xmlns:a16="http://schemas.microsoft.com/office/drawing/2014/main" id="{C1DB9C02-BFA9-4142-8B8A-386A5DD8C2F4}"/>
               </a:ext>
             </a:extLst>
           </p:cNvPr>
@@ -1923,7 +1923,7 @@
           <p:cNvPr id="12" name="canonical-metric-2-value">
             <a:extLst xmlns:a="http://schemas.openxmlformats.org/drawingml/2006/main">
               <a:ext uri="{FF2B5EF4-FFF2-40B4-BE49-F238E27FC236}">
-                <a16:creationId xmlns:a16="http://schemas.microsoft.com/office/drawing/2014/main" id="{478E6CA7-6CE3-4936-A03D-6DE071C5D6AA}"/>
+                <a16:creationId xmlns:a16="http://schemas.microsoft.com/office/drawing/2014/main" id="{5D9C21A4-045E-4D36-BB7B-D7284D9D44DC}"/>
               </a:ext>
             </a:extLst>
           </p:cNvPr>
@@ -1963,7 +1963,7 @@
           <p:cNvPr id="13" name="canonical-metric-2-detail">
             <a:extLst xmlns:a="http://schemas.openxmlformats.org/drawingml/2006/main">
               <a:ext uri="{FF2B5EF4-FFF2-40B4-BE49-F238E27FC236}">
-                <a16:creationId xmlns:a16="http://schemas.microsoft.com/office/drawing/2014/main" id="{DD3C98C4-D3EA-4F1F-88D4-F54A2328A756}"/>
+                <a16:creationId xmlns:a16="http://schemas.microsoft.com/office/drawing/2014/main" id="{D7F1698A-0A35-4977-89C1-5A3BA7E1DEC8}"/>
               </a:ext>
             </a:extLst>
           </p:cNvPr>
@@ -2003,7 +2003,7 @@
           <p:cNvPr id="14" name="canonical-metric-3-surface">
             <a:extLst xmlns:a="http://schemas.openxmlformats.org/drawingml/2006/main">
               <a:ext uri="{FF2B5EF4-FFF2-40B4-BE49-F238E27FC236}">
-                <a16:creationId xmlns:a16="http://schemas.microsoft.com/office/drawing/2014/main" id="{49268A70-097C-42B4-89CF-38F3A936A59F}"/>
+                <a16:creationId xmlns:a16="http://schemas.microsoft.com/office/drawing/2014/main" id="{A3B0543C-A34A-476C-9BAE-CDB74F09E136}"/>
               </a:ext>
             </a:extLst>
           </p:cNvPr>
@@ -2038,7 +2038,7 @@
           <p:cNvPr id="15" name="canonical-metric-3-label">
             <a:extLst xmlns:a="http://schemas.openxmlformats.org/drawingml/2006/main">
               <a:ext uri="{FF2B5EF4-FFF2-40B4-BE49-F238E27FC236}">
-                <a16:creationId xmlns:a16="http://schemas.microsoft.com/office/drawing/2014/main" id="{52DCB95D-17D1-4F77-9CBE-81616A70DD45}"/>
+                <a16:creationId xmlns:a16="http://schemas.microsoft.com/office/drawing/2014/main" id="{FE7633D9-CF52-41DF-83CC-7D95FAADC4AB}"/>
               </a:ext>
             </a:extLst>
           </p:cNvPr>
@@ -2078,7 +2078,7 @@
           <p:cNvPr id="16" name="canonical-metric-3-value">
             <a:extLst xmlns:a="http://schemas.openxmlformats.org/drawingml/2006/main">
               <a:ext uri="{FF2B5EF4-FFF2-40B4-BE49-F238E27FC236}">
-                <a16:creationId xmlns:a16="http://schemas.microsoft.com/office/drawing/2014/main" id="{01AD811F-E156-4F8E-A000-9A8296E49DF5}"/>
+                <a16:creationId xmlns:a16="http://schemas.microsoft.com/office/drawing/2014/main" id="{7B9D49B0-7F23-4A87-99D3-87F265CC5107}"/>
               </a:ext>
             </a:extLst>
           </p:cNvPr>
@@ -2118,7 +2118,7 @@
           <p:cNvPr id="17" name="canonical-metric-3-detail">
             <a:extLst xmlns:a="http://schemas.openxmlformats.org/drawingml/2006/main">
               <a:ext uri="{FF2B5EF4-FFF2-40B4-BE49-F238E27FC236}">
-                <a16:creationId xmlns:a16="http://schemas.microsoft.com/office/drawing/2014/main" id="{6B7EAF22-D855-406B-A52B-AEC4213CF973}"/>
+                <a16:creationId xmlns:a16="http://schemas.microsoft.com/office/drawing/2014/main" id="{0EB30359-1A68-4ECA-A8A3-1ADCD51165A4}"/>
               </a:ext>
             </a:extLst>
           </p:cNvPr>
@@ -2156,7 +2156,7 @@
     </p:spTree>
     <p:extLst>
       <p:ext uri="{BB962C8B-B14F-4D97-AF65-F5344CB8AC3E}">
-        <p14:creationId xmlns:p14="http://schemas.microsoft.com/office/powerpoint/2010/main" val="413739363"/>
+        <p14:creationId xmlns:p14="http://schemas.microsoft.com/office/powerpoint/2010/main" val="1735243444"/>
       </p:ext>
     </p:extLst>
   </p:cSld>
@@ -2187,7 +2187,7 @@
           <p:cNvPr id="1" name="judgmentkit-section-header-label">
             <a:extLst xmlns:a="http://schemas.openxmlformats.org/drawingml/2006/main">
               <a:ext uri="{FF2B5EF4-FFF2-40B4-BE49-F238E27FC236}">
-                <a16:creationId xmlns:a16="http://schemas.microsoft.com/office/drawing/2014/main" id="{DBADBFFC-E3C1-42A0-9B3F-5525AFFCD550}"/>
+                <a16:creationId xmlns:a16="http://schemas.microsoft.com/office/drawing/2014/main" id="{8752F37D-DDBF-4622-9293-63BE1F29D3A9}"/>
               </a:ext>
             </a:extLst>
           </p:cNvPr>
@@ -2227,7 +2227,7 @@
           <p:cNvPr id="2" name="judgmentkit-section-header-title">
             <a:extLst xmlns:a="http://schemas.openxmlformats.org/drawingml/2006/main">
               <a:ext uri="{FF2B5EF4-FFF2-40B4-BE49-F238E27FC236}">
-                <a16:creationId xmlns:a16="http://schemas.microsoft.com/office/drawing/2014/main" id="{579ECA83-4A22-4B54-A815-D9AE808C60C1}"/>
+                <a16:creationId xmlns:a16="http://schemas.microsoft.com/office/drawing/2014/main" id="{FADB1B0D-DFE8-4C73-9D23-35E87854C988}"/>
               </a:ext>
             </a:extLst>
           </p:cNvPr>
@@ -2239,7 +2239,7 @@
         <p:spPr>
           <a:xfrm xmlns:a="http://schemas.openxmlformats.org/drawingml/2006/main">
             <a:off x="685800" y="742950"/>
-            <a:ext cx="10820400" cy="914400"/>
+            <a:ext cx="10820400" cy="552450"/>
           </a:xfrm>
           <a:prstGeom xmlns:a="http://schemas.openxmlformats.org/drawingml/2006/main" prst="rect">
             <a:avLst/>
@@ -2267,7 +2267,7 @@
           <p:cNvPr id="3" name="judgmentkit-evidence-panel-surface">
             <a:extLst xmlns:a="http://schemas.openxmlformats.org/drawingml/2006/main">
               <a:ext uri="{FF2B5EF4-FFF2-40B4-BE49-F238E27FC236}">
-                <a16:creationId xmlns:a16="http://schemas.microsoft.com/office/drawing/2014/main" id="{324E8A49-158C-4B81-8D0E-20C68FC99395}"/>
+                <a16:creationId xmlns:a16="http://schemas.microsoft.com/office/drawing/2014/main" id="{8ECAB8FA-84A3-4EE2-87CC-5E7A1F53FA15}"/>
               </a:ext>
             </a:extLst>
           </p:cNvPr>
@@ -2302,7 +2302,7 @@
           <p:cNvPr id="4" name="judgmentkit-evidence-panel-title">
             <a:extLst xmlns:a="http://schemas.openxmlformats.org/drawingml/2006/main">
               <a:ext uri="{FF2B5EF4-FFF2-40B4-BE49-F238E27FC236}">
-                <a16:creationId xmlns:a16="http://schemas.microsoft.com/office/drawing/2014/main" id="{B8FB7A17-2DF1-4BAA-B712-83891FA03BC1}"/>
+                <a16:creationId xmlns:a16="http://schemas.microsoft.com/office/drawing/2014/main" id="{AE8BE6FB-AB98-4198-930B-465DE8FB5BD8}"/>
               </a:ext>
             </a:extLst>
           </p:cNvPr>
@@ -2342,7 +2342,7 @@
           <p:cNvPr id="5" name="judgmentkit-evidence-panel-body">
             <a:extLst xmlns:a="http://schemas.openxmlformats.org/drawingml/2006/main">
               <a:ext uri="{FF2B5EF4-FFF2-40B4-BE49-F238E27FC236}">
-                <a16:creationId xmlns:a16="http://schemas.microsoft.com/office/drawing/2014/main" id="{E5BB95CA-2D8D-44EC-9345-EC5A01D8349B}"/>
+                <a16:creationId xmlns:a16="http://schemas.microsoft.com/office/drawing/2014/main" id="{D59EA74C-6580-49E1-B826-20587CAEB679}"/>
               </a:ext>
             </a:extLst>
           </p:cNvPr>
@@ -2406,7 +2406,7 @@
           <p:cNvPr id="6" name="judgmentkit-risk-callout-surface">
             <a:extLst xmlns:a="http://schemas.openxmlformats.org/drawingml/2006/main">
               <a:ext uri="{FF2B5EF4-FFF2-40B4-BE49-F238E27FC236}">
-                <a16:creationId xmlns:a16="http://schemas.microsoft.com/office/drawing/2014/main" id="{FFB9294C-4A5A-4155-81C0-04A54D718153}"/>
+                <a16:creationId xmlns:a16="http://schemas.microsoft.com/office/drawing/2014/main" id="{864B2195-08B5-4F34-8FB0-8EB310521B27}"/>
               </a:ext>
             </a:extLst>
           </p:cNvPr>
@@ -2441,7 +2441,7 @@
           <p:cNvPr id="7" name="judgmentkit-risk-callout-title">
             <a:extLst xmlns:a="http://schemas.openxmlformats.org/drawingml/2006/main">
               <a:ext uri="{FF2B5EF4-FFF2-40B4-BE49-F238E27FC236}">
-                <a16:creationId xmlns:a16="http://schemas.microsoft.com/office/drawing/2014/main" id="{C5CCDE8A-3705-4A12-AAE1-C6221C63C21B}"/>
+                <a16:creationId xmlns:a16="http://schemas.microsoft.com/office/drawing/2014/main" id="{5D7ED5C8-6A13-437D-B57A-83CE24AE5867}"/>
               </a:ext>
             </a:extLst>
           </p:cNvPr>
@@ -2481,7 +2481,7 @@
           <p:cNvPr id="8" name="judgmentkit-risk-callout-body">
             <a:extLst xmlns:a="http://schemas.openxmlformats.org/drawingml/2006/main">
               <a:ext uri="{FF2B5EF4-FFF2-40B4-BE49-F238E27FC236}">
-                <a16:creationId xmlns:a16="http://schemas.microsoft.com/office/drawing/2014/main" id="{D3988DFA-5309-410D-BFC9-B1B78F6F37C3}"/>
+                <a16:creationId xmlns:a16="http://schemas.microsoft.com/office/drawing/2014/main" id="{52D7B771-84CA-441C-887A-27DBADA638BE}"/>
               </a:ext>
             </a:extLst>
           </p:cNvPr>
@@ -2533,7 +2533,7 @@
           <p:cNvPr id="9" name="judgmentkit-handoff-receipt-surface">
             <a:extLst xmlns:a="http://schemas.openxmlformats.org/drawingml/2006/main">
               <a:ext uri="{FF2B5EF4-FFF2-40B4-BE49-F238E27FC236}">
-                <a16:creationId xmlns:a16="http://schemas.microsoft.com/office/drawing/2014/main" id="{B434601D-4227-4CD4-815C-C5FF9D08A077}"/>
+                <a16:creationId xmlns:a16="http://schemas.microsoft.com/office/drawing/2014/main" id="{E07B4D80-98E1-4376-8ED5-205FC5114047}"/>
               </a:ext>
             </a:extLst>
           </p:cNvPr>
@@ -2568,7 +2568,7 @@
           <p:cNvPr id="10" name="judgmentkit-handoff-receipt-title">
             <a:extLst xmlns:a="http://schemas.openxmlformats.org/drawingml/2006/main">
               <a:ext uri="{FF2B5EF4-FFF2-40B4-BE49-F238E27FC236}">
-                <a16:creationId xmlns:a16="http://schemas.microsoft.com/office/drawing/2014/main" id="{5C4B5225-3910-4A97-B30D-2880C4E3C961}"/>
+                <a16:creationId xmlns:a16="http://schemas.microsoft.com/office/drawing/2014/main" id="{2ADB3DD7-BFE7-47AA-ACDE-63D064D91517}"/>
               </a:ext>
             </a:extLst>
           </p:cNvPr>
@@ -2608,7 +2608,7 @@
           <p:cNvPr id="11" name="judgmentkit-handoff-receipt-body">
             <a:extLst xmlns:a="http://schemas.openxmlformats.org/drawingml/2006/main">
               <a:ext uri="{FF2B5EF4-FFF2-40B4-BE49-F238E27FC236}">
-                <a16:creationId xmlns:a16="http://schemas.microsoft.com/office/drawing/2014/main" id="{C413FE42-FD7F-4971-82B4-29EF079A7C65}"/>
+                <a16:creationId xmlns:a16="http://schemas.microsoft.com/office/drawing/2014/main" id="{2D3C6780-553E-4029-8017-AF7FDFBF7878}"/>
               </a:ext>
             </a:extLst>
           </p:cNvPr>
@@ -2646,7 +2646,7 @@
     </p:spTree>
     <p:extLst>
       <p:ext uri="{BB962C8B-B14F-4D97-AF65-F5344CB8AC3E}">
-        <p14:creationId xmlns:p14="http://schemas.microsoft.com/office/powerpoint/2010/main" val="1353852943"/>
+        <p14:creationId xmlns:p14="http://schemas.microsoft.com/office/powerpoint/2010/main" val="133608008"/>
       </p:ext>
     </p:extLst>
   </p:cSld>
@@ -2677,7 +2677,7 @@
           <p:cNvPr id="1" name="judgmentkit-section-header-label">
             <a:extLst xmlns:a="http://schemas.openxmlformats.org/drawingml/2006/main">
               <a:ext uri="{FF2B5EF4-FFF2-40B4-BE49-F238E27FC236}">
-                <a16:creationId xmlns:a16="http://schemas.microsoft.com/office/drawing/2014/main" id="{93E84FE7-A258-4C87-BE7B-BD9423A5C45B}"/>
+                <a16:creationId xmlns:a16="http://schemas.microsoft.com/office/drawing/2014/main" id="{06CEADA5-0436-4727-8C4F-E386C52AD3C0}"/>
               </a:ext>
             </a:extLst>
           </p:cNvPr>
@@ -2717,7 +2717,7 @@
           <p:cNvPr id="2" name="judgmentkit-section-header-title">
             <a:extLst xmlns:a="http://schemas.openxmlformats.org/drawingml/2006/main">
               <a:ext uri="{FF2B5EF4-FFF2-40B4-BE49-F238E27FC236}">
-                <a16:creationId xmlns:a16="http://schemas.microsoft.com/office/drawing/2014/main" id="{8B1C893B-3A54-4A60-8231-4D9B4395F875}"/>
+                <a16:creationId xmlns:a16="http://schemas.microsoft.com/office/drawing/2014/main" id="{18DB032A-F103-481C-9F8C-0C078C0598D4}"/>
               </a:ext>
             </a:extLst>
           </p:cNvPr>
@@ -2729,7 +2729,7 @@
         <p:spPr>
           <a:xfrm xmlns:a="http://schemas.openxmlformats.org/drawingml/2006/main">
             <a:off x="685800" y="742950"/>
-            <a:ext cx="10820400" cy="914400"/>
+            <a:ext cx="10820400" cy="552450"/>
           </a:xfrm>
           <a:prstGeom xmlns:a="http://schemas.openxmlformats.org/drawingml/2006/main" prst="rect">
             <a:avLst/>
@@ -2757,7 +2757,7 @@
           <p:cNvPr id="3" name="judgmentkit-media-frame">
             <a:extLst xmlns:a="http://schemas.openxmlformats.org/drawingml/2006/main">
               <a:ext uri="{FF2B5EF4-FFF2-40B4-BE49-F238E27FC236}">
-                <a16:creationId xmlns:a16="http://schemas.microsoft.com/office/drawing/2014/main" id="{E79A668E-2762-4557-AC9D-8EBB2084CCEB}"/>
+                <a16:creationId xmlns:a16="http://schemas.microsoft.com/office/drawing/2014/main" id="{D07452E2-CA45-4DFF-AFFE-4F53F63518CB}"/>
               </a:ext>
             </a:extLst>
           </p:cNvPr>
@@ -2799,14 +2799,14 @@
         </p:xfrm>
         <a:graphic xmlns:a="http://schemas.openxmlformats.org/drawingml/2006/main">
           <a:graphicData uri="http://schemas.openxmlformats.org/drawingml/2006/chart">
-            <c:chart xmlns:r="http://schemas.openxmlformats.org/officeDocument/2006/relationships" xmlns:c="http://schemas.openxmlformats.org/drawingml/2006/chart" r:id="Rabfed9e51d0841d2"/>
+            <c:chart xmlns:r="http://schemas.openxmlformats.org/officeDocument/2006/relationships" xmlns:c="http://schemas.openxmlformats.org/drawingml/2006/chart" r:id="R8dcde1ec9f5b4bb9"/>
           </a:graphicData>
         </a:graphic>
       </p:graphicFrame>
     </p:spTree>
     <p:extLst>
       <p:ext uri="{BB962C8B-B14F-4D97-AF65-F5344CB8AC3E}">
-        <p14:creationId xmlns:p14="http://schemas.microsoft.com/office/powerpoint/2010/main" val="1336040462"/>
+        <p14:creationId xmlns:p14="http://schemas.microsoft.com/office/powerpoint/2010/main" val="1817401624"/>
       </p:ext>
     </p:extLst>
   </p:cSld>
@@ -2837,7 +2837,7 @@
           <p:cNvPr id="1" name="judgmentkit-section-header-label">
             <a:extLst xmlns:a="http://schemas.openxmlformats.org/drawingml/2006/main">
               <a:ext uri="{FF2B5EF4-FFF2-40B4-BE49-F238E27FC236}">
-                <a16:creationId xmlns:a16="http://schemas.microsoft.com/office/drawing/2014/main" id="{2A1E9F05-C512-4195-92EA-E59492838F17}"/>
+                <a16:creationId xmlns:a16="http://schemas.microsoft.com/office/drawing/2014/main" id="{0DEE0C0F-B156-4328-9DF0-A1AA1AA54E3A}"/>
               </a:ext>
             </a:extLst>
           </p:cNvPr>
@@ -2877,7 +2877,7 @@
           <p:cNvPr id="2" name="judgmentkit-section-header-title">
             <a:extLst xmlns:a="http://schemas.openxmlformats.org/drawingml/2006/main">
               <a:ext uri="{FF2B5EF4-FFF2-40B4-BE49-F238E27FC236}">
-                <a16:creationId xmlns:a16="http://schemas.microsoft.com/office/drawing/2014/main" id="{9C4F8741-4E50-4C27-869E-ED31EE788977}"/>
+                <a16:creationId xmlns:a16="http://schemas.microsoft.com/office/drawing/2014/main" id="{E36B58CE-4111-48CE-A24D-7CEA4AE5F8D8}"/>
               </a:ext>
             </a:extLst>
           </p:cNvPr>
@@ -2889,7 +2889,7 @@
         <p:spPr>
           <a:xfrm xmlns:a="http://schemas.openxmlformats.org/drawingml/2006/main">
             <a:off x="685800" y="742950"/>
-            <a:ext cx="10820400" cy="914400"/>
+            <a:ext cx="10820400" cy="552450"/>
           </a:xfrm>
           <a:prstGeom xmlns:a="http://schemas.openxmlformats.org/drawingml/2006/main" prst="rect">
             <a:avLst/>
@@ -3092,7 +3092,7 @@
           <p:cNvPr id="4" name="judgmentkit-handoff-receipt-surface">
             <a:extLst xmlns:a="http://schemas.openxmlformats.org/drawingml/2006/main">
               <a:ext uri="{FF2B5EF4-FFF2-40B4-BE49-F238E27FC236}">
-                <a16:creationId xmlns:a16="http://schemas.microsoft.com/office/drawing/2014/main" id="{3B83D51D-4E33-4B7F-A29B-1A41CB3F0622}"/>
+                <a16:creationId xmlns:a16="http://schemas.microsoft.com/office/drawing/2014/main" id="{257DB331-AE4B-4934-B96D-805D61637A92}"/>
               </a:ext>
             </a:extLst>
           </p:cNvPr>
@@ -3127,7 +3127,7 @@
           <p:cNvPr id="5" name="judgmentkit-handoff-receipt-title">
             <a:extLst xmlns:a="http://schemas.openxmlformats.org/drawingml/2006/main">
               <a:ext uri="{FF2B5EF4-FFF2-40B4-BE49-F238E27FC236}">
-                <a16:creationId xmlns:a16="http://schemas.microsoft.com/office/drawing/2014/main" id="{3DBE748D-38B0-4B3E-9E42-BCC6A7EB6E84}"/>
+                <a16:creationId xmlns:a16="http://schemas.microsoft.com/office/drawing/2014/main" id="{8BBC685C-DCBA-4556-8773-B24166F77F0C}"/>
               </a:ext>
             </a:extLst>
           </p:cNvPr>
@@ -3167,7 +3167,7 @@
           <p:cNvPr id="6" name="judgmentkit-handoff-receipt-body">
             <a:extLst xmlns:a="http://schemas.openxmlformats.org/drawingml/2006/main">
               <a:ext uri="{FF2B5EF4-FFF2-40B4-BE49-F238E27FC236}">
-                <a16:creationId xmlns:a16="http://schemas.microsoft.com/office/drawing/2014/main" id="{02D1ED43-49B6-414C-9B85-0B42458453E8}"/>
+                <a16:creationId xmlns:a16="http://schemas.microsoft.com/office/drawing/2014/main" id="{7E07C917-D0F3-44D5-8200-832C4495F9E0}"/>
               </a:ext>
             </a:extLst>
           </p:cNvPr>
@@ -3205,7 +3205,7 @@
     </p:spTree>
     <p:extLst>
       <p:ext uri="{BB962C8B-B14F-4D97-AF65-F5344CB8AC3E}">
-        <p14:creationId xmlns:p14="http://schemas.microsoft.com/office/powerpoint/2010/main" val="1137586105"/>
+        <p14:creationId xmlns:p14="http://schemas.microsoft.com/office/powerpoint/2010/main" val="1734766872"/>
       </p:ext>
     </p:extLst>
   </p:cSld>
@@ -3220,19 +3220,19 @@
         <a:srgbClr val="171717"/>
       </a:dk1>
       <a:lt1>
-        <a:srgbClr val="F8F7F2"/>
+        <a:srgbClr val="FFFFFF"/>
       </a:lt1>
       <a:dk2>
-        <a:srgbClr val="61615C"/>
+        <a:srgbClr val="666666"/>
       </a:dk2>
       <a:lt2>
-        <a:srgbClr val="FFFFFF"/>
+        <a:srgbClr val="F4F4F4"/>
       </a:lt2>
       <a:accent1>
-        <a:srgbClr val="245F73"/>
+        <a:srgbClr val="156082"/>
       </a:accent1>
       <a:accent2>
-        <a:srgbClr val="23615F"/>
+        <a:srgbClr val="467886"/>
       </a:accent2>
       <a:accent3>
         <a:srgbClr val="2E6B48"/>
@@ -3244,13 +3244,13 @@
         <a:srgbClr val="8F342F"/>
       </a:accent5>
       <a:accent6>
-        <a:srgbClr val="D7D3C8"/>
+        <a:srgbClr val="D9D9D9"/>
       </a:accent6>
       <a:hlink>
-        <a:srgbClr val="245F73"/>
+        <a:srgbClr val="156082"/>
       </a:hlink>
       <a:folHlink>
-        <a:srgbClr val="23615F"/>
+        <a:srgbClr val="467886"/>
       </a:folHlink>
     </a:clrScheme>
     <a:fontScheme name="Office">

</xml_diff>